<commit_message>
Deck: readable lever-C flag; rebuild
Co-Authored-By: Claude Opus 5.5 <noreply@anthropic.com>
</commit_message>
<xml_diff>
--- a/analysis/deck/OP_Mainnet_Revenue_BI_Lead.pptx
+++ b/analysis/deck/OP_Mainnet_Revenue_BI_Lead.pptx
@@ -10683,7 +10683,7 @@
                           </a:solidFill>
                           <a:latin typeface="Helvetica Neue"/>
                         </a:rPr>
-                        <a:t>True</a:t>
+                        <a:t>Yes</a:t>
                       </a:r>
                     </a:p>
                   </a:txBody>
@@ -10705,7 +10705,7 @@
                           </a:solidFill>
                           <a:latin typeface="Helvetica Neue"/>
                         </a:rPr>
-                        <a:t>True</a:t>
+                        <a:t>Yes</a:t>
                       </a:r>
                     </a:p>
                   </a:txBody>
@@ -10727,7 +10727,7 @@
                           </a:solidFill>
                           <a:latin typeface="Helvetica Neue"/>
                         </a:rPr>
-                        <a:t>True</a:t>
+                        <a:t>Yes</a:t>
                       </a:r>
                     </a:p>
                   </a:txBody>

</xml_diff>

<commit_message>
Deck: remove speaker notes and data-pull dates
Co-Authored-By: Claude Opus 5.5 <noreply@anthropic.com>
</commit_message>
<xml_diff>
--- a/analysis/deck/OP_Mainnet_Revenue_BI_Lead.pptx
+++ b/analysis/deck/OP_Mainnet_Revenue_BI_Lead.pptx
@@ -8,27 +8,27 @@
     <p:sldId id="256" r:id="rId7"/>
     <p:sldId id="257" r:id="rId8"/>
     <p:sldId id="258" r:id="rId9"/>
-    <p:sldId id="259" r:id="rId11"/>
-    <p:sldId id="260" r:id="rId12"/>
-    <p:sldId id="261" r:id="rId13"/>
-    <p:sldId id="262" r:id="rId14"/>
-    <p:sldId id="263" r:id="rId15"/>
-    <p:sldId id="264" r:id="rId16"/>
-    <p:sldId id="265" r:id="rId17"/>
-    <p:sldId id="266" r:id="rId18"/>
-    <p:sldId id="267" r:id="rId19"/>
-    <p:sldId id="268" r:id="rId20"/>
-    <p:sldId id="269" r:id="rId21"/>
-    <p:sldId id="270" r:id="rId22"/>
-    <p:sldId id="271" r:id="rId23"/>
-    <p:sldId id="272" r:id="rId24"/>
-    <p:sldId id="273" r:id="rId25"/>
-    <p:sldId id="274" r:id="rId26"/>
-    <p:sldId id="275" r:id="rId27"/>
-    <p:sldId id="276" r:id="rId28"/>
-    <p:sldId id="277" r:id="rId29"/>
-    <p:sldId id="278" r:id="rId30"/>
-    <p:sldId id="279" r:id="rId31"/>
+    <p:sldId id="259" r:id="rId10"/>
+    <p:sldId id="260" r:id="rId11"/>
+    <p:sldId id="261" r:id="rId12"/>
+    <p:sldId id="262" r:id="rId13"/>
+    <p:sldId id="263" r:id="rId14"/>
+    <p:sldId id="264" r:id="rId15"/>
+    <p:sldId id="265" r:id="rId16"/>
+    <p:sldId id="266" r:id="rId17"/>
+    <p:sldId id="267" r:id="rId18"/>
+    <p:sldId id="268" r:id="rId19"/>
+    <p:sldId id="269" r:id="rId20"/>
+    <p:sldId id="270" r:id="rId21"/>
+    <p:sldId id="271" r:id="rId22"/>
+    <p:sldId id="272" r:id="rId23"/>
+    <p:sldId id="273" r:id="rId24"/>
+    <p:sldId id="274" r:id="rId25"/>
+    <p:sldId id="275" r:id="rId26"/>
+    <p:sldId id="276" r:id="rId27"/>
+    <p:sldId id="277" r:id="rId28"/>
+    <p:sldId id="278" r:id="rId29"/>
+    <p:sldId id="279" r:id="rId30"/>
   </p:sldIdLst>
   <p:sldSz cx="12191695" cy="6858000" type="screen4x3"/>
   <p:notesSz cx="6858000" cy="9144000"/>
@@ -128,1196 +128,6 @@
     </a:lvl9pPr>
   </p:defaultTextStyle>
 </p:presentation>
-</file>
-
-<file path=ppt/notesMasters/notesMaster1.xml><?xml version="1.0" encoding="utf-8"?>
-<p:notesMaster xmlns:a="http://schemas.openxmlformats.org/drawingml/2006/main" xmlns:p="http://schemas.openxmlformats.org/presentationml/2006/main" xmlns:r="http://schemas.openxmlformats.org/officeDocument/2006/relationships">
-  <p:cSld>
-    <p:bg>
-      <p:bgRef idx="1001">
-        <a:schemeClr val="bg1"/>
-      </p:bgRef>
-    </p:bg>
-    <p:spTree>
-      <p:nvGrpSpPr>
-        <p:cNvPr id="1" name=""/>
-        <p:cNvGrpSpPr/>
-        <p:nvPr/>
-      </p:nvGrpSpPr>
-      <p:grpSpPr>
-        <a:xfrm>
-          <a:off x="0" y="0"/>
-          <a:ext cx="0" cy="0"/>
-          <a:chOff x="0" y="0"/>
-          <a:chExt cx="0" cy="0"/>
-        </a:xfrm>
-      </p:grpSpPr>
-      <p:sp>
-        <p:nvSpPr>
-          <p:cNvPr id="2" name="Header Placeholder 1"/>
-          <p:cNvSpPr>
-            <a:spLocks noGrp="1"/>
-          </p:cNvSpPr>
-          <p:nvPr>
-            <p:ph type="hdr" sz="quarter"/>
-          </p:nvPr>
-        </p:nvSpPr>
-        <p:spPr>
-          <a:xfrm>
-            <a:off x="0" y="0"/>
-            <a:ext cx="2971800" cy="457200"/>
-          </a:xfrm>
-          <a:prstGeom prst="rect">
-            <a:avLst/>
-          </a:prstGeom>
-        </p:spPr>
-        <p:txBody>
-          <a:bodyPr vert="horz" lIns="91440" tIns="45720" rIns="91440" bIns="45720" rtlCol="0"/>
-          <a:lstStyle>
-            <a:lvl1pPr algn="l">
-              <a:defRPr sz="1200"/>
-            </a:lvl1pPr>
-          </a:lstStyle>
-          <a:p>
-            <a:endParaRPr lang="en-US"/>
-          </a:p>
-        </p:txBody>
-      </p:sp>
-      <p:sp>
-        <p:nvSpPr>
-          <p:cNvPr id="3" name="Date Placeholder 2"/>
-          <p:cNvSpPr>
-            <a:spLocks noGrp="1"/>
-          </p:cNvSpPr>
-          <p:nvPr>
-            <p:ph type="dt" idx="1"/>
-          </p:nvPr>
-        </p:nvSpPr>
-        <p:spPr>
-          <a:xfrm>
-            <a:off x="3884613" y="0"/>
-            <a:ext cx="2971800" cy="457200"/>
-          </a:xfrm>
-          <a:prstGeom prst="rect">
-            <a:avLst/>
-          </a:prstGeom>
-        </p:spPr>
-        <p:txBody>
-          <a:bodyPr vert="horz" lIns="91440" tIns="45720" rIns="91440" bIns="45720" rtlCol="0"/>
-          <a:lstStyle>
-            <a:lvl1pPr algn="r">
-              <a:defRPr sz="1200"/>
-            </a:lvl1pPr>
-          </a:lstStyle>
-          <a:p>
-            <a:fld id="{0F89C1C7-3DCD-1040-A9CF-14679D8B5DDD}" type="datetimeFigureOut">
-              <a:rPr lang="en-US" smtClean="0"/>
-              <a:t>10/17/16</a:t>
-            </a:fld>
-            <a:endParaRPr lang="en-US"/>
-          </a:p>
-        </p:txBody>
-      </p:sp>
-      <p:sp>
-        <p:nvSpPr>
-          <p:cNvPr id="4" name="Slide Image Placeholder 3"/>
-          <p:cNvSpPr>
-            <a:spLocks noGrp="1" noRot="1" noChangeAspect="1"/>
-          </p:cNvSpPr>
-          <p:nvPr>
-            <p:ph type="sldImg" idx="2"/>
-          </p:nvPr>
-        </p:nvSpPr>
-        <p:spPr>
-          <a:xfrm>
-            <a:off x="1143000" y="685800"/>
-            <a:ext cx="4572000" cy="3429000"/>
-          </a:xfrm>
-          <a:prstGeom prst="rect">
-            <a:avLst/>
-          </a:prstGeom>
-          <a:noFill/>
-          <a:ln w="12700">
-            <a:solidFill>
-              <a:prstClr val="black"/>
-            </a:solidFill>
-          </a:ln>
-        </p:spPr>
-        <p:txBody>
-          <a:bodyPr vert="horz" lIns="91440" tIns="45720" rIns="91440" bIns="45720" rtlCol="0" anchor="ctr"/>
-          <a:lstStyle/>
-          <a:p>
-            <a:endParaRPr lang="en-US"/>
-          </a:p>
-        </p:txBody>
-      </p:sp>
-      <p:sp>
-        <p:nvSpPr>
-          <p:cNvPr id="5" name="Notes Placeholder 4"/>
-          <p:cNvSpPr>
-            <a:spLocks noGrp="1"/>
-          </p:cNvSpPr>
-          <p:nvPr>
-            <p:ph type="body" sz="quarter" idx="3"/>
-          </p:nvPr>
-        </p:nvSpPr>
-        <p:spPr>
-          <a:xfrm>
-            <a:off x="685800" y="4343400"/>
-            <a:ext cx="5486400" cy="4114800"/>
-          </a:xfrm>
-          <a:prstGeom prst="rect">
-            <a:avLst/>
-          </a:prstGeom>
-        </p:spPr>
-        <p:txBody>
-          <a:bodyPr vert="horz" lIns="91440" tIns="45720" rIns="91440" bIns="45720" rtlCol="0"/>
-          <a:lstStyle/>
-          <a:p>
-            <a:pPr lvl="0"/>
-            <a:r>
-              <a:rPr lang="en-US" smtClean="0"/>
-              <a:t>Click to edit Master text styles</a:t>
-            </a:r>
-          </a:p>
-          <a:p>
-            <a:pPr lvl="1"/>
-            <a:r>
-              <a:rPr lang="en-US" smtClean="0"/>
-              <a:t>Second level</a:t>
-            </a:r>
-          </a:p>
-          <a:p>
-            <a:pPr lvl="2"/>
-            <a:r>
-              <a:rPr lang="en-US" smtClean="0"/>
-              <a:t>Third level</a:t>
-            </a:r>
-          </a:p>
-          <a:p>
-            <a:pPr lvl="3"/>
-            <a:r>
-              <a:rPr lang="en-US" smtClean="0"/>
-              <a:t>Fourth level</a:t>
-            </a:r>
-          </a:p>
-          <a:p>
-            <a:pPr lvl="4"/>
-            <a:r>
-              <a:rPr lang="en-US" smtClean="0"/>
-              <a:t>Fifth level</a:t>
-            </a:r>
-            <a:endParaRPr lang="en-US"/>
-          </a:p>
-        </p:txBody>
-      </p:sp>
-      <p:sp>
-        <p:nvSpPr>
-          <p:cNvPr id="6" name="Footer Placeholder 5"/>
-          <p:cNvSpPr>
-            <a:spLocks noGrp="1"/>
-          </p:cNvSpPr>
-          <p:nvPr>
-            <p:ph type="ftr" sz="quarter" idx="4"/>
-          </p:nvPr>
-        </p:nvSpPr>
-        <p:spPr>
-          <a:xfrm>
-            <a:off x="0" y="8685213"/>
-            <a:ext cx="2971800" cy="457200"/>
-          </a:xfrm>
-          <a:prstGeom prst="rect">
-            <a:avLst/>
-          </a:prstGeom>
-        </p:spPr>
-        <p:txBody>
-          <a:bodyPr vert="horz" lIns="91440" tIns="45720" rIns="91440" bIns="45720" rtlCol="0" anchor="b"/>
-          <a:lstStyle>
-            <a:lvl1pPr algn="l">
-              <a:defRPr sz="1200"/>
-            </a:lvl1pPr>
-          </a:lstStyle>
-          <a:p>
-            <a:endParaRPr lang="en-US"/>
-          </a:p>
-        </p:txBody>
-      </p:sp>
-      <p:sp>
-        <p:nvSpPr>
-          <p:cNvPr id="7" name="Slide Number Placeholder 6"/>
-          <p:cNvSpPr>
-            <a:spLocks noGrp="1"/>
-          </p:cNvSpPr>
-          <p:nvPr>
-            <p:ph type="sldNum" sz="quarter" idx="5"/>
-          </p:nvPr>
-        </p:nvSpPr>
-        <p:spPr>
-          <a:xfrm>
-            <a:off x="3884613" y="8685213"/>
-            <a:ext cx="2971800" cy="457200"/>
-          </a:xfrm>
-          <a:prstGeom prst="rect">
-            <a:avLst/>
-          </a:prstGeom>
-        </p:spPr>
-        <p:txBody>
-          <a:bodyPr vert="horz" lIns="91440" tIns="45720" rIns="91440" bIns="45720" rtlCol="0" anchor="b"/>
-          <a:lstStyle>
-            <a:lvl1pPr algn="r">
-              <a:defRPr sz="1200"/>
-            </a:lvl1pPr>
-          </a:lstStyle>
-          <a:p>
-            <a:fld id="{BB5E49A5-4136-284D-997B-48E1D791AD67}" type="slidenum">
-              <a:rPr lang="en-US" smtClean="0"/>
-              <a:t>‹#›</a:t>
-            </a:fld>
-            <a:endParaRPr lang="en-US"/>
-          </a:p>
-        </p:txBody>
-      </p:sp>
-    </p:spTree>
-    <p:extLst>
-      <p:ext uri="{BB962C8B-B14F-4D97-AF65-F5344CB8AC3E}">
-        <p14:creationId xmlns:p14="http://schemas.microsoft.com/office/powerpoint/2010/main" val="2623252185"/>
-      </p:ext>
-    </p:extLst>
-  </p:cSld>
-  <p:clrMap bg1="lt1" tx1="dk1" bg2="lt2" tx2="dk2" accent1="accent1" accent2="accent2" accent3="accent3" accent4="accent4" accent5="accent5" accent6="accent6" hlink="hlink" folHlink="folHlink"/>
-  <p:notesStyle>
-    <a:lvl1pPr marL="0" algn="l" defTabSz="457200" rtl="0" eaLnBrk="1" latinLnBrk="0" hangingPunct="1">
-      <a:defRPr sz="1200" kern="1200">
-        <a:solidFill>
-          <a:schemeClr val="tx1"/>
-        </a:solidFill>
-        <a:latin typeface="+mn-lt"/>
-        <a:ea typeface="+mn-ea"/>
-        <a:cs typeface="+mn-cs"/>
-      </a:defRPr>
-    </a:lvl1pPr>
-    <a:lvl2pPr marL="457200" algn="l" defTabSz="457200" rtl="0" eaLnBrk="1" latinLnBrk="0" hangingPunct="1">
-      <a:defRPr sz="1200" kern="1200">
-        <a:solidFill>
-          <a:schemeClr val="tx1"/>
-        </a:solidFill>
-        <a:latin typeface="+mn-lt"/>
-        <a:ea typeface="+mn-ea"/>
-        <a:cs typeface="+mn-cs"/>
-      </a:defRPr>
-    </a:lvl2pPr>
-    <a:lvl3pPr marL="914400" algn="l" defTabSz="457200" rtl="0" eaLnBrk="1" latinLnBrk="0" hangingPunct="1">
-      <a:defRPr sz="1200" kern="1200">
-        <a:solidFill>
-          <a:schemeClr val="tx1"/>
-        </a:solidFill>
-        <a:latin typeface="+mn-lt"/>
-        <a:ea typeface="+mn-ea"/>
-        <a:cs typeface="+mn-cs"/>
-      </a:defRPr>
-    </a:lvl3pPr>
-    <a:lvl4pPr marL="1371600" algn="l" defTabSz="457200" rtl="0" eaLnBrk="1" latinLnBrk="0" hangingPunct="1">
-      <a:defRPr sz="1200" kern="1200">
-        <a:solidFill>
-          <a:schemeClr val="tx1"/>
-        </a:solidFill>
-        <a:latin typeface="+mn-lt"/>
-        <a:ea typeface="+mn-ea"/>
-        <a:cs typeface="+mn-cs"/>
-      </a:defRPr>
-    </a:lvl4pPr>
-    <a:lvl5pPr marL="1828800" algn="l" defTabSz="457200" rtl="0" eaLnBrk="1" latinLnBrk="0" hangingPunct="1">
-      <a:defRPr sz="1200" kern="1200">
-        <a:solidFill>
-          <a:schemeClr val="tx1"/>
-        </a:solidFill>
-        <a:latin typeface="+mn-lt"/>
-        <a:ea typeface="+mn-ea"/>
-        <a:cs typeface="+mn-cs"/>
-      </a:defRPr>
-    </a:lvl5pPr>
-    <a:lvl6pPr marL="2286000" algn="l" defTabSz="457200" rtl="0" eaLnBrk="1" latinLnBrk="0" hangingPunct="1">
-      <a:defRPr sz="1200" kern="1200">
-        <a:solidFill>
-          <a:schemeClr val="tx1"/>
-        </a:solidFill>
-        <a:latin typeface="+mn-lt"/>
-        <a:ea typeface="+mn-ea"/>
-        <a:cs typeface="+mn-cs"/>
-      </a:defRPr>
-    </a:lvl6pPr>
-    <a:lvl7pPr marL="2743200" algn="l" defTabSz="457200" rtl="0" eaLnBrk="1" latinLnBrk="0" hangingPunct="1">
-      <a:defRPr sz="1200" kern="1200">
-        <a:solidFill>
-          <a:schemeClr val="tx1"/>
-        </a:solidFill>
-        <a:latin typeface="+mn-lt"/>
-        <a:ea typeface="+mn-ea"/>
-        <a:cs typeface="+mn-cs"/>
-      </a:defRPr>
-    </a:lvl7pPr>
-    <a:lvl8pPr marL="3200400" algn="l" defTabSz="457200" rtl="0" eaLnBrk="1" latinLnBrk="0" hangingPunct="1">
-      <a:defRPr sz="1200" kern="1200">
-        <a:solidFill>
-          <a:schemeClr val="tx1"/>
-        </a:solidFill>
-        <a:latin typeface="+mn-lt"/>
-        <a:ea typeface="+mn-ea"/>
-        <a:cs typeface="+mn-cs"/>
-      </a:defRPr>
-    </a:lvl8pPr>
-    <a:lvl9pPr marL="3657600" algn="l" defTabSz="457200" rtl="0" eaLnBrk="1" latinLnBrk="0" hangingPunct="1">
-      <a:defRPr sz="1200" kern="1200">
-        <a:solidFill>
-          <a:schemeClr val="tx1"/>
-        </a:solidFill>
-        <a:latin typeface="+mn-lt"/>
-        <a:ea typeface="+mn-ea"/>
-        <a:cs typeface="+mn-cs"/>
-      </a:defRPr>
-    </a:lvl9pPr>
-  </p:notesStyle>
-</p:notesMaster>
-</file>
-
-<file path=ppt/notesSlides/notesSlide1.xml><?xml version="1.0" encoding="utf-8"?>
-<p:notes xmlns:a="http://schemas.openxmlformats.org/drawingml/2006/main" xmlns:p="http://schemas.openxmlformats.org/presentationml/2006/main" xmlns:r="http://schemas.openxmlformats.org/officeDocument/2006/relationships">
-  <p:cSld>
-    <p:spTree>
-      <p:nvGrpSpPr>
-        <p:cNvPr id="1" name=""/>
-        <p:cNvGrpSpPr/>
-        <p:nvPr/>
-      </p:nvGrpSpPr>
-      <p:grpSpPr>
-        <a:xfrm>
-          <a:off x="0" y="0"/>
-          <a:ext cx="0" cy="0"/>
-          <a:chOff x="0" y="0"/>
-          <a:chExt cx="0" cy="0"/>
-        </a:xfrm>
-      </p:grpSpPr>
-      <p:sp>
-        <p:nvSpPr>
-          <p:cNvPr id="2" name="Slide Image Placeholder 1"/>
-          <p:cNvSpPr>
-            <a:spLocks noGrp="1"/>
-          </p:cNvSpPr>
-          <p:nvPr>
-            <p:ph type="sldImg" idx="2"/>
-          </p:nvPr>
-        </p:nvSpPr>
-        <p:spPr/>
-      </p:sp>
-      <p:sp>
-        <p:nvSpPr>
-          <p:cNvPr id="3" name="Notes Placeholder 2"/>
-          <p:cNvSpPr>
-            <a:spLocks noGrp="1"/>
-          </p:cNvSpPr>
-          <p:nvPr>
-            <p:ph type="body" idx="3" sz="quarter"/>
-          </p:nvPr>
-        </p:nvSpPr>
-        <p:spPr/>
-        <p:txBody>
-          <a:bodyPr/>
-          <a:lstStyle/>
-          <a:p>
-            <a:r>
-              <a:t>Think of OP Mainnet as a toll road. Blockspace is the lane capacity we sell, and gas is the unit we meter it in, like kilowatt-hours. The sequencer is OP's toll booth: it orders transactions and collects the fees. Our cost is the L1 data cost, which is what we pay Ethereum to post a copy of every transaction for security. Our share is the fees minus that cost. We compared the last 12 months with the 258 days before, per day, so the uneven period lengths do not distort the picture. Customers are whoever's transactions pay the toll.</a:t>
-            </a:r>
-          </a:p>
-        </p:txBody>
-      </p:sp>
-      <p:sp>
-        <p:nvSpPr>
-          <p:cNvPr id="4" name="Slide Number Placeholder 3"/>
-          <p:cNvSpPr>
-            <a:spLocks noGrp="1"/>
-          </p:cNvSpPr>
-          <p:nvPr>
-            <p:ph type="sldNum" idx="5" sz="quarter"/>
-          </p:nvPr>
-        </p:nvSpPr>
-        <p:spPr/>
-      </p:sp>
-    </p:spTree>
-  </p:cSld>
-  <p:clrMapOvr>
-    <a:masterClrMapping/>
-  </p:clrMapOvr>
-</p:notes>
-</file>
-
-<file path=ppt/notesSlides/notesSlide10.xml><?xml version="1.0" encoding="utf-8"?>
-<p:notes xmlns:a="http://schemas.openxmlformats.org/drawingml/2006/main" xmlns:p="http://schemas.openxmlformats.org/presentationml/2006/main" xmlns:r="http://schemas.openxmlformats.org/officeDocument/2006/relationships">
-  <p:cSld>
-    <p:spTree>
-      <p:nvGrpSpPr>
-        <p:cNvPr id="1" name=""/>
-        <p:cNvGrpSpPr/>
-        <p:nvPr/>
-      </p:nvGrpSpPr>
-      <p:grpSpPr>
-        <a:xfrm>
-          <a:off x="0" y="0"/>
-          <a:ext cx="0" cy="0"/>
-          <a:chOff x="0" y="0"/>
-          <a:chExt cx="0" cy="0"/>
-        </a:xfrm>
-      </p:grpSpPr>
-      <p:sp>
-        <p:nvSpPr>
-          <p:cNvPr id="2" name="Slide Image Placeholder 1"/>
-          <p:cNvSpPr>
-            <a:spLocks noGrp="1"/>
-          </p:cNvSpPr>
-          <p:nvPr>
-            <p:ph type="sldImg" idx="2"/>
-          </p:nvPr>
-        </p:nvSpPr>
-        <p:spPr/>
-      </p:sp>
-      <p:sp>
-        <p:nvSpPr>
-          <p:cNvPr id="3" name="Notes Placeholder 2"/>
-          <p:cNvSpPr>
-            <a:spLocks noGrp="1"/>
-          </p:cNvSpPr>
-          <p:nvPr>
-            <p:ph type="body" idx="3" sz="quarter"/>
-          </p:nvPr>
-        </p:nvSpPr>
-        <p:spPr/>
-        <p:txBody>
-          <a:bodyPr/>
-          <a:lstStyle/>
-          <a:p>
-            <a:r>
-              <a:t>To be clear about what this plan achieves: the levers mostly defend revenue. Without them we drift to $0.90M. With them we hold roughly flat at $1.19M. The model is simple: base-load gas times price, plus a spike premium, converted at the ETH price, minus the Ethereum posting cost. The minimum base fee is a setting that has been live on the OP Stack since December 2025 (the Jovian upgrade), so this is configuration rather than new engineering. Lever B looks small on our income statement. Its real value is in ecosystem fees, stablecoin volume and deposits.</a:t>
-            </a:r>
-          </a:p>
-        </p:txBody>
-      </p:sp>
-      <p:sp>
-        <p:nvSpPr>
-          <p:cNvPr id="4" name="Slide Number Placeholder 3"/>
-          <p:cNvSpPr>
-            <a:spLocks noGrp="1"/>
-          </p:cNvSpPr>
-          <p:nvPr>
-            <p:ph type="sldNum" idx="5" sz="quarter"/>
-          </p:nvPr>
-        </p:nvSpPr>
-        <p:spPr/>
-      </p:sp>
-    </p:spTree>
-  </p:cSld>
-  <p:clrMapOvr>
-    <a:masterClrMapping/>
-  </p:clrMapOvr>
-</p:notes>
-</file>
-
-<file path=ppt/notesSlides/notesSlide11.xml><?xml version="1.0" encoding="utf-8"?>
-<p:notes xmlns:a="http://schemas.openxmlformats.org/drawingml/2006/main" xmlns:p="http://schemas.openxmlformats.org/presentationml/2006/main" xmlns:r="http://schemas.openxmlformats.org/officeDocument/2006/relationships">
-  <p:cSld>
-    <p:spTree>
-      <p:nvGrpSpPr>
-        <p:cNvPr id="1" name=""/>
-        <p:cNvGrpSpPr/>
-        <p:nvPr/>
-      </p:nvGrpSpPr>
-      <p:grpSpPr>
-        <a:xfrm>
-          <a:off x="0" y="0"/>
-          <a:ext cx="0" cy="0"/>
-          <a:chOff x="0" y="0"/>
-          <a:chExt cx="0" cy="0"/>
-        </a:xfrm>
-      </p:grpSpPr>
-      <p:sp>
-        <p:nvSpPr>
-          <p:cNvPr id="2" name="Slide Image Placeholder 1"/>
-          <p:cNvSpPr>
-            <a:spLocks noGrp="1"/>
-          </p:cNvSpPr>
-          <p:nvPr>
-            <p:ph type="sldImg" idx="2"/>
-          </p:nvPr>
-        </p:nvSpPr>
-        <p:spPr/>
-      </p:sp>
-      <p:sp>
-        <p:nvSpPr>
-          <p:cNvPr id="3" name="Notes Placeholder 2"/>
-          <p:cNvSpPr>
-            <a:spLocks noGrp="1"/>
-          </p:cNvSpPr>
-          <p:nvPr>
-            <p:ph type="body" idx="3" sz="quarter"/>
-          </p:nvPr>
-        </p:nvSpPr>
-        <p:spPr/>
-        <p:txBody>
-          <a:bodyPr/>
-          <a:lstStyle/>
-          <a:p>
-            <a:r>
-              <a:t>Each bar changes one assumption at a time. ETH price matters most, and we cannot control it. Of the things we can influence, the biggest unknown is bot elasticity, meaning how much bots cut their usage when the price rises. We assumed -0.6, which is cautious next to the -0.38 we observed. Even at -1.2, where bots react far more strongly than we assumed, the base case is $0.98M. That is still above the $0.90M no-action line. This is why we recommend a staged rollout: each stage measures the real bot response before we go further.</a:t>
-            </a:r>
-          </a:p>
-        </p:txBody>
-      </p:sp>
-      <p:sp>
-        <p:nvSpPr>
-          <p:cNvPr id="4" name="Slide Number Placeholder 3"/>
-          <p:cNvSpPr>
-            <a:spLocks noGrp="1"/>
-          </p:cNvSpPr>
-          <p:nvPr>
-            <p:ph type="sldNum" idx="5" sz="quarter"/>
-          </p:nvPr>
-        </p:nvSpPr>
-        <p:spPr/>
-      </p:sp>
-    </p:spTree>
-  </p:cSld>
-  <p:clrMapOvr>
-    <a:masterClrMapping/>
-  </p:clrMapOvr>
-</p:notes>
-</file>
-
-<file path=ppt/notesSlides/notesSlide12.xml><?xml version="1.0" encoding="utf-8"?>
-<p:notes xmlns:a="http://schemas.openxmlformats.org/drawingml/2006/main" xmlns:p="http://schemas.openxmlformats.org/presentationml/2006/main" xmlns:r="http://schemas.openxmlformats.org/officeDocument/2006/relationships">
-  <p:cSld>
-    <p:spTree>
-      <p:nvGrpSpPr>
-        <p:cNvPr id="1" name=""/>
-        <p:cNvGrpSpPr/>
-        <p:nvPr/>
-      </p:nvGrpSpPr>
-      <p:grpSpPr>
-        <a:xfrm>
-          <a:off x="0" y="0"/>
-          <a:ext cx="0" cy="0"/>
-          <a:chOff x="0" y="0"/>
-          <a:chExt cx="0" cy="0"/>
-        </a:xfrm>
-      </p:grpSpPr>
-      <p:sp>
-        <p:nvSpPr>
-          <p:cNvPr id="2" name="Slide Image Placeholder 1"/>
-          <p:cNvSpPr>
-            <a:spLocks noGrp="1"/>
-          </p:cNvSpPr>
-          <p:nvPr>
-            <p:ph type="sldImg" idx="2"/>
-          </p:nvPr>
-        </p:nvSpPr>
-        <p:spPr/>
-      </p:sp>
-      <p:sp>
-        <p:nvSpPr>
-          <p:cNvPr id="3" name="Notes Placeholder 2"/>
-          <p:cNvSpPr>
-            <a:spLocks noGrp="1"/>
-          </p:cNvSpPr>
-          <p:nvPr>
-            <p:ph type="body" idx="3" sz="quarter"/>
-          </p:nvPr>
-        </p:nvSpPr>
-        <p:spPr/>
-        <p:txBody>
-          <a:bodyPr/>
-          <a:lstStyle/>
-          <a:p>
-            <a:r>
-              <a:t>This is the pricing trade-off in one picture. Each step up the floor adds revenue, but each step also widens the gap with Base, Arbitrum and other chains that bots can move to. We stop at 2.5 mwei because users barely notice it: a typical transaction costs about $0.0014. Bots absorb most of the volume loss in the model. Before we act, the team needs to confirm OP Mainnet's current minimum base fee setting in the on-chain configuration, because this analysis did not verify it. Higher floors are an option for later, once we have the stage-one data.</a:t>
-            </a:r>
-          </a:p>
-        </p:txBody>
-      </p:sp>
-      <p:sp>
-        <p:nvSpPr>
-          <p:cNvPr id="4" name="Slide Number Placeholder 3"/>
-          <p:cNvSpPr>
-            <a:spLocks noGrp="1"/>
-          </p:cNvSpPr>
-          <p:nvPr>
-            <p:ph type="sldNum" idx="5" sz="quarter"/>
-          </p:nvPr>
-        </p:nvSpPr>
-        <p:spPr/>
-      </p:sp>
-    </p:spTree>
-  </p:cSld>
-  <p:clrMapOvr>
-    <a:masterClrMapping/>
-  </p:clrMapOvr>
-</p:notes>
-</file>
-
-<file path=ppt/notesSlides/notesSlide2.xml><?xml version="1.0" encoding="utf-8"?>
-<p:notes xmlns:a="http://schemas.openxmlformats.org/drawingml/2006/main" xmlns:p="http://schemas.openxmlformats.org/presentationml/2006/main" xmlns:r="http://schemas.openxmlformats.org/officeDocument/2006/relationships">
-  <p:cSld>
-    <p:spTree>
-      <p:nvGrpSpPr>
-        <p:cNvPr id="1" name=""/>
-        <p:cNvGrpSpPr/>
-        <p:nvPr/>
-      </p:nvGrpSpPr>
-      <p:grpSpPr>
-        <a:xfrm>
-          <a:off x="0" y="0"/>
-          <a:ext cx="0" cy="0"/>
-          <a:chOff x="0" y="0"/>
-          <a:chExt cx="0" cy="0"/>
-        </a:xfrm>
-      </p:grpSpPr>
-      <p:sp>
-        <p:nvSpPr>
-          <p:cNvPr id="2" name="Slide Image Placeholder 1"/>
-          <p:cNvSpPr>
-            <a:spLocks noGrp="1"/>
-          </p:cNvSpPr>
-          <p:nvPr>
-            <p:ph type="sldImg" idx="2"/>
-          </p:nvPr>
-        </p:nvSpPr>
-        <p:spPr/>
-      </p:sp>
-      <p:sp>
-        <p:nvSpPr>
-          <p:cNvPr id="3" name="Notes Placeholder 2"/>
-          <p:cNvSpPr>
-            <a:spLocks noGrp="1"/>
-          </p:cNvSpPr>
-          <p:nvPr>
-            <p:ph type="body" idx="3" sz="quarter"/>
-          </p:nvPr>
-        </p:nvSpPr>
-        <p:spPr/>
-        <p:txBody>
-          <a:bodyPr/>
-          <a:lstStyle/>
-          <a:p>
-            <a:r>
-              <a:t>The headline for Finance is that costs are not the problem. We keep roughly 96 to 97 cents of every fee dollar. The problem is the top line. Daily fees are down 70%, and the current monthly run-rate is a small fraction of January 2025. Two data sources disagree on the Ethereum posting cost over the 64 days where they overlap, but either way net revenue stays at about 95 to 97% of gross, so the conclusion does not depend on which one we use. We tried rebuilding the cost directly from on-chain data, but the free data provider rate-limited us. That remains a follow-up for the Data team.</a:t>
-            </a:r>
-          </a:p>
-        </p:txBody>
-      </p:sp>
-      <p:sp>
-        <p:nvSpPr>
-          <p:cNvPr id="4" name="Slide Number Placeholder 3"/>
-          <p:cNvSpPr>
-            <a:spLocks noGrp="1"/>
-          </p:cNvSpPr>
-          <p:nvPr>
-            <p:ph type="sldNum" idx="5" sz="quarter"/>
-          </p:nvPr>
-        </p:nvSpPr>
-        <p:spPr/>
-      </p:sp>
-    </p:spTree>
-  </p:cSld>
-  <p:clrMapOvr>
-    <a:masterClrMapping/>
-  </p:clrMapOvr>
-</p:notes>
-</file>
-
-<file path=ppt/notesSlides/notesSlide3.xml><?xml version="1.0" encoding="utf-8"?>
-<p:notes xmlns:a="http://schemas.openxmlformats.org/drawingml/2006/main" xmlns:p="http://schemas.openxmlformats.org/presentationml/2006/main" xmlns:r="http://schemas.openxmlformats.org/officeDocument/2006/relationships">
-  <p:cSld>
-    <p:spTree>
-      <p:nvGrpSpPr>
-        <p:cNvPr id="1" name=""/>
-        <p:cNvGrpSpPr/>
-        <p:nvPr/>
-      </p:nvGrpSpPr>
-      <p:grpSpPr>
-        <a:xfrm>
-          <a:off x="0" y="0"/>
-          <a:ext cx="0" cy="0"/>
-          <a:chOff x="0" y="0"/>
-          <a:chExt cx="0" cy="0"/>
-        </a:xfrm>
-      </p:grpSpPr>
-      <p:sp>
-        <p:nvSpPr>
-          <p:cNvPr id="2" name="Slide Image Placeholder 1"/>
-          <p:cNvSpPr>
-            <a:spLocks noGrp="1"/>
-          </p:cNvSpPr>
-          <p:nvPr>
-            <p:ph type="sldImg" idx="2"/>
-          </p:nvPr>
-        </p:nvSpPr>
-        <p:spPr/>
-      </p:sp>
-      <p:sp>
-        <p:nvSpPr>
-          <p:cNvPr id="3" name="Notes Placeholder 2"/>
-          <p:cNvSpPr>
-            <a:spLocks noGrp="1"/>
-          </p:cNvSpPr>
-          <p:nvPr>
-            <p:ph type="body" idx="3" sz="quarter"/>
-          </p:nvPr>
-        </p:nvSpPr>
-        <p:spPr/>
-        <p:txBody>
-          <a:bodyPr/>
-          <a:lstStyle/>
-          <a:p>
-            <a:r>
-              <a:t>This slide splits the drop in daily fees exactly into four pieces. Volume actually helped: we processed 71% more transactions per day. A higher ETH price also helped slightly, adding $0.5k a day. What hurt was price. The base fee, the automatic posted price per unit of gas, falls toward zero when blocks are not full, and it fell 76%. This also gives us a natural experiment. Blockspace got 76% cheaper, but transactions rose only 0.38% for every 1% price drop. Cutting the price did not buy volume, so a modest price increase should not lose much of it.</a:t>
-            </a:r>
-          </a:p>
-        </p:txBody>
-      </p:sp>
-      <p:sp>
-        <p:nvSpPr>
-          <p:cNvPr id="4" name="Slide Number Placeholder 3"/>
-          <p:cNvSpPr>
-            <a:spLocks noGrp="1"/>
-          </p:cNvSpPr>
-          <p:nvPr>
-            <p:ph type="sldNum" idx="5" sz="quarter"/>
-          </p:nvPr>
-        </p:nvSpPr>
-        <p:spPr/>
-      </p:sp>
-    </p:spTree>
-  </p:cSld>
-  <p:clrMapOvr>
-    <a:masterClrMapping/>
-  </p:clrMapOvr>
-</p:notes>
-</file>
-
-<file path=ppt/notesSlides/notesSlide4.xml><?xml version="1.0" encoding="utf-8"?>
-<p:notes xmlns:a="http://schemas.openxmlformats.org/drawingml/2006/main" xmlns:p="http://schemas.openxmlformats.org/presentationml/2006/main" xmlns:r="http://schemas.openxmlformats.org/officeDocument/2006/relationships">
-  <p:cSld>
-    <p:spTree>
-      <p:nvGrpSpPr>
-        <p:cNvPr id="1" name=""/>
-        <p:cNvGrpSpPr/>
-        <p:nvPr/>
-      </p:nvGrpSpPr>
-      <p:grpSpPr>
-        <a:xfrm>
-          <a:off x="0" y="0"/>
-          <a:ext cx="0" cy="0"/>
-          <a:chOff x="0" y="0"/>
-          <a:chExt cx="0" cy="0"/>
-        </a:xfrm>
-      </p:grpSpPr>
-      <p:sp>
-        <p:nvSpPr>
-          <p:cNvPr id="2" name="Slide Image Placeholder 1"/>
-          <p:cNvSpPr>
-            <a:spLocks noGrp="1"/>
-          </p:cNvSpPr>
-          <p:nvPr>
-            <p:ph type="sldImg" idx="2"/>
-          </p:nvPr>
-        </p:nvSpPr>
-        <p:spPr/>
-      </p:sp>
-      <p:sp>
-        <p:nvSpPr>
-          <p:cNvPr id="3" name="Notes Placeholder 2"/>
-          <p:cNvSpPr>
-            <a:spLocks noGrp="1"/>
-          </p:cNvSpPr>
-          <p:nvPr>
-            <p:ph type="body" idx="3" sz="quarter"/>
-          </p:nvPr>
-        </p:nvSpPr>
-        <p:spPr/>
-        <p:txBody>
-          <a:bodyPr/>
-          <a:lstStyle/>
-          <a:p>
-            <a:r>
-              <a:t>mwei is the unit for the price of blockspace. One mwei is a trillionth of an ETH, charged per unit of gas. On a normal day blockspace is almost free. When markets crash, trading bots compete to get their transactions in first, and some searchers pay up to $350 per transaction. One day, October 10 2025, earned a fifth of the year. For Finance this means last year's total overstates the repeatable base. Our base case assumes no crash of that size: we take 0.67x of last year's congestion premium, which is last year without the top day.</a:t>
-            </a:r>
-          </a:p>
-        </p:txBody>
-      </p:sp>
-      <p:sp>
-        <p:nvSpPr>
-          <p:cNvPr id="4" name="Slide Number Placeholder 3"/>
-          <p:cNvSpPr>
-            <a:spLocks noGrp="1"/>
-          </p:cNvSpPr>
-          <p:nvPr>
-            <p:ph type="sldNum" idx="5" sz="quarter"/>
-          </p:nvPr>
-        </p:nvSpPr>
-        <p:spPr/>
-      </p:sp>
-    </p:spTree>
-  </p:cSld>
-  <p:clrMapOvr>
-    <a:masterClrMapping/>
-  </p:clrMapOvr>
-</p:notes>
-</file>
-
-<file path=ppt/notesSlides/notesSlide5.xml><?xml version="1.0" encoding="utf-8"?>
-<p:notes xmlns:a="http://schemas.openxmlformats.org/drawingml/2006/main" xmlns:p="http://schemas.openxmlformats.org/presentationml/2006/main" xmlns:r="http://schemas.openxmlformats.org/officeDocument/2006/relationships">
-  <p:cSld>
-    <p:spTree>
-      <p:nvGrpSpPr>
-        <p:cNvPr id="1" name=""/>
-        <p:cNvGrpSpPr/>
-        <p:nvPr/>
-      </p:nvGrpSpPr>
-      <p:grpSpPr>
-        <a:xfrm>
-          <a:off x="0" y="0"/>
-          <a:ext cx="0" cy="0"/>
-          <a:chOff x="0" y="0"/>
-          <a:chExt cx="0" cy="0"/>
-        </a:xfrm>
-      </p:grpSpPr>
-      <p:sp>
-        <p:nvSpPr>
-          <p:cNvPr id="2" name="Slide Image Placeholder 1"/>
-          <p:cNvSpPr>
-            <a:spLocks noGrp="1"/>
-          </p:cNvSpPr>
-          <p:nvPr>
-            <p:ph type="sldImg" idx="2"/>
-          </p:nvPr>
-        </p:nvSpPr>
-        <p:spPr/>
-      </p:sp>
-      <p:sp>
-        <p:nvSpPr>
-          <p:cNvPr id="3" name="Notes Placeholder 2"/>
-          <p:cNvSpPr>
-            <a:spLocks noGrp="1"/>
-          </p:cNvSpPr>
-          <p:nvPr>
-            <p:ph type="body" idx="3" sz="quarter"/>
-          </p:nvPr>
-        </p:nvSpPr>
-        <p:spPr/>
-        <p:txBody>
-          <a:bodyPr/>
-          <a:lstStyle/>
-          <a:p>
-            <a:r>
-              <a:t>To answer the question directly: the apps make the money. They collected $41.3M in fees. Gas paid by the contracts we could track for those apps was $111k, and that is a floor because some app contracts fall below our tracking threshold. ether.fi is the clearest example. It is a card issuer that moved about 70k cards onto OP Mainnet in 2026. It generated $1,849 of app fees for every $1 of gas it paid OP. The economic value created on OP Mainnet is large, and our toll on it is small. Growing app activity therefore helps the ecosystem far more than it helps our direct fees.</a:t>
-            </a:r>
-          </a:p>
-        </p:txBody>
-      </p:sp>
-      <p:sp>
-        <p:nvSpPr>
-          <p:cNvPr id="4" name="Slide Number Placeholder 3"/>
-          <p:cNvSpPr>
-            <a:spLocks noGrp="1"/>
-          </p:cNvSpPr>
-          <p:nvPr>
-            <p:ph type="sldNum" idx="5" sz="quarter"/>
-          </p:nvPr>
-        </p:nvSpPr>
-        <p:spPr/>
-      </p:sp>
-    </p:spTree>
-  </p:cSld>
-  <p:clrMapOvr>
-    <a:masterClrMapping/>
-  </p:clrMapOvr>
-</p:notes>
-</file>
-
-<file path=ppt/notesSlides/notesSlide6.xml><?xml version="1.0" encoding="utf-8"?>
-<p:notes xmlns:a="http://schemas.openxmlformats.org/drawingml/2006/main" xmlns:p="http://schemas.openxmlformats.org/presentationml/2006/main" xmlns:r="http://schemas.openxmlformats.org/officeDocument/2006/relationships">
-  <p:cSld>
-    <p:spTree>
-      <p:nvGrpSpPr>
-        <p:cNvPr id="1" name=""/>
-        <p:cNvGrpSpPr/>
-        <p:nvPr/>
-      </p:nvGrpSpPr>
-      <p:grpSpPr>
-        <a:xfrm>
-          <a:off x="0" y="0"/>
-          <a:ext cx="0" cy="0"/>
-          <a:chOff x="0" y="0"/>
-          <a:chExt cx="0" cy="0"/>
-        </a:xfrm>
-      </p:grpSpPr>
-      <p:sp>
-        <p:nvSpPr>
-          <p:cNvPr id="2" name="Slide Image Placeholder 1"/>
-          <p:cNvSpPr>
-            <a:spLocks noGrp="1"/>
-          </p:cNvSpPr>
-          <p:nvPr>
-            <p:ph type="sldImg" idx="2"/>
-          </p:nvPr>
-        </p:nvSpPr>
-        <p:spPr/>
-      </p:sp>
-      <p:sp>
-        <p:nvSpPr>
-          <p:cNvPr id="3" name="Notes Placeholder 2"/>
-          <p:cNvSpPr>
-            <a:spLocks noGrp="1"/>
-          </p:cNvSpPr>
-          <p:nvPr>
-            <p:ph type="body" idx="3" sz="quarter"/>
-          </p:nvPr>
-        </p:nvSpPr>
-        <p:spPr/>
-        <p:txBody>
-          <a:bodyPr/>
-          <a:lstStyle/>
-          <a:p>
-            <a:r>
-              <a:t>MEV stands for maximal extractable value. It is the profit trading bots earn by being first in line, through arbitrage and liquidations. Together with unnamed automated contracts, bots pay about two-thirds of our revenue. They send huge volumes at very low prices. That makes them the group a price floor affects most, and also the biggest unknown in our forecast. One caveat: we label a contract as a bot with a rule of thumb (five or fewer senders a day, or 50 or more transactions per sender-day). Labels cover about 340 of 1,082 addresses, so these splits are directional.</a:t>
-            </a:r>
-          </a:p>
-        </p:txBody>
-      </p:sp>
-      <p:sp>
-        <p:nvSpPr>
-          <p:cNvPr id="4" name="Slide Number Placeholder 3"/>
-          <p:cNvSpPr>
-            <a:spLocks noGrp="1"/>
-          </p:cNvSpPr>
-          <p:nvPr>
-            <p:ph type="sldNum" idx="5" sz="quarter"/>
-          </p:nvPr>
-        </p:nvSpPr>
-        <p:spPr/>
-      </p:sp>
-    </p:spTree>
-  </p:cSld>
-  <p:clrMapOvr>
-    <a:masterClrMapping/>
-  </p:clrMapOvr>
-</p:notes>
-</file>
-
-<file path=ppt/notesSlides/notesSlide7.xml><?xml version="1.0" encoding="utf-8"?>
-<p:notes xmlns:a="http://schemas.openxmlformats.org/drawingml/2006/main" xmlns:p="http://schemas.openxmlformats.org/presentationml/2006/main" xmlns:r="http://schemas.openxmlformats.org/officeDocument/2006/relationships">
-  <p:cSld>
-    <p:spTree>
-      <p:nvGrpSpPr>
-        <p:cNvPr id="1" name=""/>
-        <p:cNvGrpSpPr/>
-        <p:nvPr/>
-      </p:nvGrpSpPr>
-      <p:grpSpPr>
-        <a:xfrm>
-          <a:off x="0" y="0"/>
-          <a:ext cx="0" cy="0"/>
-          <a:chOff x="0" y="0"/>
-          <a:chExt cx="0" cy="0"/>
-        </a:xfrm>
-      </p:grpSpPr>
-      <p:sp>
-        <p:nvSpPr>
-          <p:cNvPr id="2" name="Slide Image Placeholder 1"/>
-          <p:cNvSpPr>
-            <a:spLocks noGrp="1"/>
-          </p:cNvSpPr>
-          <p:nvPr>
-            <p:ph type="sldImg" idx="2"/>
-          </p:nvPr>
-        </p:nvSpPr>
-        <p:spPr/>
-      </p:sp>
-      <p:sp>
-        <p:nvSpPr>
-          <p:cNvPr id="3" name="Notes Placeholder 2"/>
-          <p:cNvSpPr>
-            <a:spLocks noGrp="1"/>
-          </p:cNvSpPr>
-          <p:nvPr>
-            <p:ph type="body" idx="3" sz="quarter"/>
-          </p:nvPr>
-        </p:nvSpPr>
-        <p:spPr/>
-        <p:txBody>
-          <a:bodyPr/>
-          <a:lstStyle/>
-          <a:p>
-            <a:r>
-              <a:t>From a BD and Finance angle, this looks like a key-account business we have never managed as one. Half our revenue comes from ten payers, and most of them are automated trading operations we do not have a relationship with. The overall concentration index is moderate because there is a long tail, but losing two or three top payers to another chain would show up in the numbers right away. Priority-fee auctions are tips that bots pay to jump the queue. They are why a few customers can pay hundreds of dollars per transaction on volatile days.</a:t>
-            </a:r>
-          </a:p>
-        </p:txBody>
-      </p:sp>
-      <p:sp>
-        <p:nvSpPr>
-          <p:cNvPr id="4" name="Slide Number Placeholder 3"/>
-          <p:cNvSpPr>
-            <a:spLocks noGrp="1"/>
-          </p:cNvSpPr>
-          <p:nvPr>
-            <p:ph type="sldNum" idx="5" sz="quarter"/>
-          </p:nvPr>
-        </p:nvSpPr>
-        <p:spPr/>
-      </p:sp>
-    </p:spTree>
-  </p:cSld>
-  <p:clrMapOvr>
-    <a:masterClrMapping/>
-  </p:clrMapOvr>
-</p:notes>
-</file>
-
-<file path=ppt/notesSlides/notesSlide8.xml><?xml version="1.0" encoding="utf-8"?>
-<p:notes xmlns:a="http://schemas.openxmlformats.org/drawingml/2006/main" xmlns:p="http://schemas.openxmlformats.org/presentationml/2006/main" xmlns:r="http://schemas.openxmlformats.org/officeDocument/2006/relationships">
-  <p:cSld>
-    <p:spTree>
-      <p:nvGrpSpPr>
-        <p:cNvPr id="1" name=""/>
-        <p:cNvGrpSpPr/>
-        <p:nvPr/>
-      </p:nvGrpSpPr>
-      <p:grpSpPr>
-        <a:xfrm>
-          <a:off x="0" y="0"/>
-          <a:ext cx="0" cy="0"/>
-          <a:chOff x="0" y="0"/>
-          <a:chExt cx="0" cy="0"/>
-        </a:xfrm>
-      </p:grpSpPr>
-      <p:sp>
-        <p:nvSpPr>
-          <p:cNvPr id="2" name="Slide Image Placeholder 1"/>
-          <p:cNvSpPr>
-            <a:spLocks noGrp="1"/>
-          </p:cNvSpPr>
-          <p:nvPr>
-            <p:ph type="sldImg" idx="2"/>
-          </p:nvPr>
-        </p:nvSpPr>
-        <p:spPr/>
-      </p:sp>
-      <p:sp>
-        <p:nvSpPr>
-          <p:cNvPr id="3" name="Notes Placeholder 2"/>
-          <p:cNvSpPr>
-            <a:spLocks noGrp="1"/>
-          </p:cNvSpPr>
-          <p:nvPr>
-            <p:ph type="body" idx="3" sz="quarter"/>
-          </p:nvPr>
-        </p:nvSpPr>
-        <p:spPr/>
-        <p:txBody>
-          <a:bodyPr/>
-          <a:lstStyle/>
-          <a:p>
-            <a:r>
-              <a:t>This is the subscription-business view of our customers. Take everyone paying at least $10 a month and look again three months later. Only about half are still paying, and the group as a whole pays 43% of what it paid before. Some of this is natural, because bots appear and disappear with trading strategies. For planning, though, it means today's revenue is not sticky. That is one reason we pair pricing with BD on payments, where issuers like ether.fi bring steady, recurring card flow instead of opportunistic trading volume.</a:t>
-            </a:r>
-          </a:p>
-        </p:txBody>
-      </p:sp>
-      <p:sp>
-        <p:nvSpPr>
-          <p:cNvPr id="4" name="Slide Number Placeholder 3"/>
-          <p:cNvSpPr>
-            <a:spLocks noGrp="1"/>
-          </p:cNvSpPr>
-          <p:nvPr>
-            <p:ph type="sldNum" idx="5" sz="quarter"/>
-          </p:nvPr>
-        </p:nvSpPr>
-        <p:spPr/>
-      </p:sp>
-    </p:spTree>
-  </p:cSld>
-  <p:clrMapOvr>
-    <a:masterClrMapping/>
-  </p:clrMapOvr>
-</p:notes>
-</file>
-
-<file path=ppt/notesSlides/notesSlide9.xml><?xml version="1.0" encoding="utf-8"?>
-<p:notes xmlns:a="http://schemas.openxmlformats.org/drawingml/2006/main" xmlns:p="http://schemas.openxmlformats.org/presentationml/2006/main" xmlns:r="http://schemas.openxmlformats.org/officeDocument/2006/relationships">
-  <p:cSld>
-    <p:spTree>
-      <p:nvGrpSpPr>
-        <p:cNvPr id="1" name=""/>
-        <p:cNvGrpSpPr/>
-        <p:nvPr/>
-      </p:nvGrpSpPr>
-      <p:grpSpPr>
-        <a:xfrm>
-          <a:off x="0" y="0"/>
-          <a:ext cx="0" cy="0"/>
-          <a:chOff x="0" y="0"/>
-          <a:chExt cx="0" cy="0"/>
-        </a:xfrm>
-      </p:grpSpPr>
-      <p:sp>
-        <p:nvSpPr>
-          <p:cNvPr id="2" name="Slide Image Placeholder 1"/>
-          <p:cNvSpPr>
-            <a:spLocks noGrp="1"/>
-          </p:cNvSpPr>
-          <p:nvPr>
-            <p:ph type="sldImg" idx="2"/>
-          </p:nvPr>
-        </p:nvSpPr>
-        <p:spPr/>
-      </p:sp>
-      <p:sp>
-        <p:nvSpPr>
-          <p:cNvPr id="3" name="Notes Placeholder 2"/>
-          <p:cNvSpPr>
-            <a:spLocks noGrp="1"/>
-          </p:cNvSpPr>
-          <p:nvPr>
-            <p:ph type="body" idx="3" sz="quarter"/>
-          </p:nvPr>
-        </p:nvSpPr>
-        <p:spPr/>
-        <p:txBody>
-          <a:bodyPr/>
-          <a:lstStyle/>
-          <a:p>
-            <a:r>
-              <a:t>We looked at other customer groups beyond direct fee payers. Stablecoin payments are the one clear growth line, and bridges have turned to net inflow. Most other indicators shrank. Exchange deposits and withdrawals fell to $4.5B a quarter from $9.4B, DeFi deposits (TVL) to $344M from $438M, DEX trading volume to $1.5B from $4.6B, and new addresses to 0.48M a quarter from 2.06M. Builders are the exception, with about 1.8k daily deployers, flat to slightly up. Base leaving the revenue share makes two things matter more: OP Mainnet's own sequencer margin, and other chains as paying OP Enterprise customers.</a:t>
-            </a:r>
-          </a:p>
-        </p:txBody>
-      </p:sp>
-      <p:sp>
-        <p:nvSpPr>
-          <p:cNvPr id="4" name="Slide Number Placeholder 3"/>
-          <p:cNvSpPr>
-            <a:spLocks noGrp="1"/>
-          </p:cNvSpPr>
-          <p:nvPr>
-            <p:ph type="sldNum" idx="5" sz="quarter"/>
-          </p:nvPr>
-        </p:nvSpPr>
-        <p:spPr/>
-      </p:sp>
-    </p:spTree>
-  </p:cSld>
-  <p:clrMapOvr>
-    <a:masterClrMapping/>
-  </p:clrMapOvr>
-</p:notes>
 </file>
 
 <file path=ppt/slideLayouts/slideLayout1.xml><?xml version="1.0" encoding="utf-8"?>
@@ -15442,7 +14252,7 @@
                 </a:solidFill>
                 <a:latin typeface="Helvetica Neue"/>
               </a:rPr>
-              <a:t>▪  DefiLlama chain fees, OP Mainnet: api.llama.fi/summary/fees/op-mainnet?dataType=dailyFees | dailyRevenue (pulled 2026-10-12)</a:t>
+              <a:t>▪  DefiLlama chain fees, OP Mainnet: api.llama.fi/summary/fees/op-mainnet?dataType=dailyFees | dailyRevenue</a:t>
             </a:r>
           </a:p>
           <a:p>
@@ -15458,7 +14268,7 @@
                 </a:solidFill>
                 <a:latin typeface="Helvetica Neue"/>
               </a:rPr>
-              <a:t>▪  growthepie fundamentals (OP Mainnet costs_total_usd, fees_paid_usd): api.growthepie.com/v1/fundamentals.json (pulled 2026-10-12)</a:t>
+              <a:t>▪  growthepie fundamentals (OP Mainnet costs_total_usd, fees_paid_usd): api.growthepie.com/v1/fundamentals.json</a:t>
             </a:r>
           </a:p>
           <a:p>
@@ -18250,324 +17060,4 @@
   </a:objectDefaults>
   <a:extraClrSchemeLst/>
 </a:theme>
-</file>
-
-<file path=ppt/theme/theme2.xml><?xml version="1.0" encoding="utf-8"?>
-<a:theme xmlns:a="http://schemas.openxmlformats.org/drawingml/2006/main" name="Office Theme">
-  <a:themeElements>
-    <a:clrScheme name="Office">
-      <a:dk1>
-        <a:sysClr val="windowText" lastClr="000000"/>
-      </a:dk1>
-      <a:lt1>
-        <a:sysClr val="window" lastClr="FFFFFF"/>
-      </a:lt1>
-      <a:dk2>
-        <a:srgbClr val="1F497D"/>
-      </a:dk2>
-      <a:lt2>
-        <a:srgbClr val="EEECE1"/>
-      </a:lt2>
-      <a:accent1>
-        <a:srgbClr val="4F81BD"/>
-      </a:accent1>
-      <a:accent2>
-        <a:srgbClr val="C0504D"/>
-      </a:accent2>
-      <a:accent3>
-        <a:srgbClr val="9BBB59"/>
-      </a:accent3>
-      <a:accent4>
-        <a:srgbClr val="8064A2"/>
-      </a:accent4>
-      <a:accent5>
-        <a:srgbClr val="4BACC6"/>
-      </a:accent5>
-      <a:accent6>
-        <a:srgbClr val="F79646"/>
-      </a:accent6>
-      <a:hlink>
-        <a:srgbClr val="0000FF"/>
-      </a:hlink>
-      <a:folHlink>
-        <a:srgbClr val="800080"/>
-      </a:folHlink>
-    </a:clrScheme>
-    <a:fontScheme name="Office">
-      <a:majorFont>
-        <a:latin typeface="Calibri"/>
-        <a:ea typeface=""/>
-        <a:cs typeface=""/>
-        <a:font script="Jpan" typeface="ＭＳ Ｐゴシック"/>
-        <a:font script="Hang" typeface="맑은 고딕"/>
-        <a:font script="Hans" typeface="宋体"/>
-        <a:font script="Hant" typeface="新細明體"/>
-        <a:font script="Arab" typeface="Times New Roman"/>
-        <a:font script="Hebr" typeface="Times New Roman"/>
-        <a:font script="Thai" typeface="Angsana New"/>
-        <a:font script="Ethi" typeface="Nyala"/>
-        <a:font script="Beng" typeface="Vrinda"/>
-        <a:font script="Gujr" typeface="Shruti"/>
-        <a:font script="Khmr" typeface="MoolBoran"/>
-        <a:font script="Knda" typeface="Tunga"/>
-        <a:font script="Guru" typeface="Raavi"/>
-        <a:font script="Cans" typeface="Euphemia"/>
-        <a:font script="Cher" typeface="Plantagenet Cherokee"/>
-        <a:font script="Yiii" typeface="Microsoft Yi Baiti"/>
-        <a:font script="Tibt" typeface="Microsoft Himalaya"/>
-        <a:font script="Thaa" typeface="MV Boli"/>
-        <a:font script="Deva" typeface="Mangal"/>
-        <a:font script="Telu" typeface="Gautami"/>
-        <a:font script="Taml" typeface="Latha"/>
-        <a:font script="Syrc" typeface="Estrangelo Edessa"/>
-        <a:font script="Orya" typeface="Kalinga"/>
-        <a:font script="Mlym" typeface="Kartika"/>
-        <a:font script="Laoo" typeface="DokChampa"/>
-        <a:font script="Sinh" typeface="Iskoola Pota"/>
-        <a:font script="Mong" typeface="Mongolian Baiti"/>
-        <a:font script="Viet" typeface="Times New Roman"/>
-        <a:font script="Uigh" typeface="Microsoft Uighur"/>
-        <a:font script="Geor" typeface="Sylfaen"/>
-      </a:majorFont>
-      <a:minorFont>
-        <a:latin typeface="Calibri"/>
-        <a:ea typeface=""/>
-        <a:cs typeface=""/>
-        <a:font script="Jpan" typeface="ＭＳ Ｐゴシック"/>
-        <a:font script="Hang" typeface="맑은 고딕"/>
-        <a:font script="Hans" typeface="宋体"/>
-        <a:font script="Hant" typeface="新細明體"/>
-        <a:font script="Arab" typeface="Arial"/>
-        <a:font script="Hebr" typeface="Arial"/>
-        <a:font script="Thai" typeface="Cordia New"/>
-        <a:font script="Ethi" typeface="Nyala"/>
-        <a:font script="Beng" typeface="Vrinda"/>
-        <a:font script="Gujr" typeface="Shruti"/>
-        <a:font script="Khmr" typeface="DaunPenh"/>
-        <a:font script="Knda" typeface="Tunga"/>
-        <a:font script="Guru" typeface="Raavi"/>
-        <a:font script="Cans" typeface="Euphemia"/>
-        <a:font script="Cher" typeface="Plantagenet Cherokee"/>
-        <a:font script="Yiii" typeface="Microsoft Yi Baiti"/>
-        <a:font script="Tibt" typeface="Microsoft Himalaya"/>
-        <a:font script="Thaa" typeface="MV Boli"/>
-        <a:font script="Deva" typeface="Mangal"/>
-        <a:font script="Telu" typeface="Gautami"/>
-        <a:font script="Taml" typeface="Latha"/>
-        <a:font script="Syrc" typeface="Estrangelo Edessa"/>
-        <a:font script="Orya" typeface="Kalinga"/>
-        <a:font script="Mlym" typeface="Kartika"/>
-        <a:font script="Laoo" typeface="DokChampa"/>
-        <a:font script="Sinh" typeface="Iskoola Pota"/>
-        <a:font script="Mong" typeface="Mongolian Baiti"/>
-        <a:font script="Viet" typeface="Arial"/>
-        <a:font script="Uigh" typeface="Microsoft Uighur"/>
-        <a:font script="Geor" typeface="Sylfaen"/>
-      </a:minorFont>
-    </a:fontScheme>
-    <a:fmtScheme name="Office">
-      <a:fillStyleLst>
-        <a:solidFill>
-          <a:schemeClr val="phClr"/>
-        </a:solidFill>
-        <a:gradFill rotWithShape="1">
-          <a:gsLst>
-            <a:gs pos="0">
-              <a:schemeClr val="phClr">
-                <a:tint val="50000"/>
-                <a:satMod val="300000"/>
-              </a:schemeClr>
-            </a:gs>
-            <a:gs pos="35000">
-              <a:schemeClr val="phClr">
-                <a:tint val="37000"/>
-                <a:satMod val="300000"/>
-              </a:schemeClr>
-            </a:gs>
-            <a:gs pos="100000">
-              <a:schemeClr val="phClr">
-                <a:tint val="15000"/>
-                <a:satMod val="350000"/>
-              </a:schemeClr>
-            </a:gs>
-          </a:gsLst>
-          <a:lin ang="16200000" scaled="1"/>
-        </a:gradFill>
-        <a:gradFill rotWithShape="1">
-          <a:gsLst>
-            <a:gs pos="0">
-              <a:schemeClr val="phClr">
-                <a:tint val="100000"/>
-                <a:shade val="100000"/>
-                <a:satMod val="130000"/>
-              </a:schemeClr>
-            </a:gs>
-            <a:gs pos="100000">
-              <a:schemeClr val="phClr">
-                <a:tint val="50000"/>
-                <a:shade val="100000"/>
-                <a:satMod val="350000"/>
-              </a:schemeClr>
-            </a:gs>
-          </a:gsLst>
-          <a:lin ang="16200000" scaled="0"/>
-        </a:gradFill>
-      </a:fillStyleLst>
-      <a:lnStyleLst>
-        <a:ln w="9525" cap="flat" cmpd="sng" algn="ctr">
-          <a:solidFill>
-            <a:schemeClr val="phClr">
-              <a:shade val="95000"/>
-              <a:satMod val="105000"/>
-            </a:schemeClr>
-          </a:solidFill>
-          <a:prstDash val="solid"/>
-        </a:ln>
-        <a:ln w="25400" cap="flat" cmpd="sng" algn="ctr">
-          <a:solidFill>
-            <a:schemeClr val="phClr"/>
-          </a:solidFill>
-          <a:prstDash val="solid"/>
-        </a:ln>
-        <a:ln w="38100" cap="flat" cmpd="sng" algn="ctr">
-          <a:solidFill>
-            <a:schemeClr val="phClr"/>
-          </a:solidFill>
-          <a:prstDash val="solid"/>
-        </a:ln>
-      </a:lnStyleLst>
-      <a:effectStyleLst>
-        <a:effectStyle>
-          <a:effectLst>
-            <a:outerShdw blurRad="40000" dist="20000" dir="5400000" rotWithShape="0">
-              <a:srgbClr val="000000">
-                <a:alpha val="38000"/>
-              </a:srgbClr>
-            </a:outerShdw>
-          </a:effectLst>
-        </a:effectStyle>
-        <a:effectStyle>
-          <a:effectLst>
-            <a:outerShdw blurRad="40000" dist="23000" dir="5400000" rotWithShape="0">
-              <a:srgbClr val="000000">
-                <a:alpha val="35000"/>
-              </a:srgbClr>
-            </a:outerShdw>
-          </a:effectLst>
-        </a:effectStyle>
-        <a:effectStyle>
-          <a:effectLst>
-            <a:outerShdw blurRad="40000" dist="23000" dir="5400000" rotWithShape="0">
-              <a:srgbClr val="000000">
-                <a:alpha val="35000"/>
-              </a:srgbClr>
-            </a:outerShdw>
-          </a:effectLst>
-          <a:scene3d>
-            <a:camera prst="orthographicFront">
-              <a:rot lat="0" lon="0" rev="0"/>
-            </a:camera>
-            <a:lightRig rig="threePt" dir="t">
-              <a:rot lat="0" lon="0" rev="1200000"/>
-            </a:lightRig>
-          </a:scene3d>
-          <a:sp3d>
-            <a:bevelT w="63500" h="25400"/>
-          </a:sp3d>
-        </a:effectStyle>
-      </a:effectStyleLst>
-      <a:bgFillStyleLst>
-        <a:solidFill>
-          <a:schemeClr val="phClr"/>
-        </a:solidFill>
-        <a:gradFill rotWithShape="1">
-          <a:gsLst>
-            <a:gs pos="0">
-              <a:schemeClr val="phClr">
-                <a:tint val="40000"/>
-                <a:satMod val="350000"/>
-              </a:schemeClr>
-            </a:gs>
-            <a:gs pos="40000">
-              <a:schemeClr val="phClr">
-                <a:tint val="45000"/>
-                <a:shade val="99000"/>
-                <a:satMod val="350000"/>
-              </a:schemeClr>
-            </a:gs>
-            <a:gs pos="100000">
-              <a:schemeClr val="phClr">
-                <a:shade val="20000"/>
-                <a:satMod val="255000"/>
-              </a:schemeClr>
-            </a:gs>
-          </a:gsLst>
-          <a:path path="circle">
-            <a:fillToRect l="50000" t="-80000" r="50000" b="180000"/>
-          </a:path>
-        </a:gradFill>
-        <a:gradFill rotWithShape="1">
-          <a:gsLst>
-            <a:gs pos="0">
-              <a:schemeClr val="phClr">
-                <a:tint val="80000"/>
-                <a:satMod val="300000"/>
-              </a:schemeClr>
-            </a:gs>
-            <a:gs pos="100000">
-              <a:schemeClr val="phClr">
-                <a:shade val="30000"/>
-                <a:satMod val="200000"/>
-              </a:schemeClr>
-            </a:gs>
-          </a:gsLst>
-          <a:path path="circle">
-            <a:fillToRect l="50000" t="50000" r="50000" b="50000"/>
-          </a:path>
-        </a:gradFill>
-      </a:bgFillStyleLst>
-    </a:fmtScheme>
-  </a:themeElements>
-  <a:objectDefaults>
-    <a:spDef>
-      <a:spPr/>
-      <a:bodyPr/>
-      <a:lstStyle/>
-      <a:style>
-        <a:lnRef idx="1">
-          <a:schemeClr val="accent1"/>
-        </a:lnRef>
-        <a:fillRef idx="3">
-          <a:schemeClr val="accent1"/>
-        </a:fillRef>
-        <a:effectRef idx="2">
-          <a:schemeClr val="accent1"/>
-        </a:effectRef>
-        <a:fontRef idx="minor">
-          <a:schemeClr val="lt1"/>
-        </a:fontRef>
-      </a:style>
-    </a:spDef>
-    <a:lnDef>
-      <a:spPr/>
-      <a:bodyPr/>
-      <a:lstStyle/>
-      <a:style>
-        <a:lnRef idx="2">
-          <a:schemeClr val="accent1"/>
-        </a:lnRef>
-        <a:fillRef idx="0">
-          <a:schemeClr val="accent1"/>
-        </a:fillRef>
-        <a:effectRef idx="1">
-          <a:schemeClr val="accent1"/>
-        </a:effectRef>
-        <a:fontRef idx="minor">
-          <a:schemeClr val="tx1"/>
-        </a:fontRef>
-      </a:style>
-    </a:lnDef>
-  </a:objectDefaults>
-  <a:extraClrSchemeLst/>
-</a:theme>
 </file>
</xml_diff>